<commit_message>
Clean up directory structure and finalize deliverables
</commit_message>
<xml_diff>
--- a/Data Science Capstone Project Report.pptx
+++ b/Data Science Capstone Project Report.pptx
@@ -3238,7 +3238,7 @@
               </a:defRPr>
             </a:pPr>
             <a:r>
-              <a:t>Project GitHub URL: https://github.com/your-username/SpaceX-Falcon9-Landing-Prediction</a:t>
+              <a:t>Project GitHub URL: https://github.com/sondthe200221/SpaceX-Falcon9-Landing-Prediction</a:t>
             </a:r>
           </a:p>
         </p:txBody>
@@ -3796,7 +3796,7 @@
               </a:defRPr>
             </a:pPr>
             <a:r>
-              <a:t>GitHub Repository Reference: https://github.com/your-username/SpaceX-Falcon9-Landing-Prediction/blob/main/5_SpaceX_EDA_SQL.ipynb</a:t>
+              <a:t>GitHub Repository Reference: https://github.com/sondthe200221/SpaceX-Falcon9-Landing-Prediction/blob/main/5_SpaceX_EDA_SQL.ipynb</a:t>
             </a:r>
           </a:p>
         </p:txBody>
@@ -4285,7 +4285,7 @@
               </a:defRPr>
             </a:pPr>
             <a:r>
-              <a:t>GitHub Repository Reference: https://github.com/your-username/SpaceX-Falcon9-Landing-Prediction/blob/main/5_SpaceX_EDA_SQL.ipynb</a:t>
+              <a:t>GitHub Repository Reference: https://github.com/sondthe200221/SpaceX-Falcon9-Landing-Prediction/blob/main/5_SpaceX_EDA_SQL.ipynb</a:t>
             </a:r>
           </a:p>
         </p:txBody>
@@ -4797,7 +4797,7 @@
               </a:defRPr>
             </a:pPr>
             <a:r>
-              <a:t>GitHub Repository Reference: https://github.com/your-username/SpaceX-Falcon9-Landing-Prediction/blob/main/6_SpaceX_Interactive_Folium.ipynb</a:t>
+              <a:t>GitHub Repository Reference: https://github.com/sondthe200221/SpaceX-Falcon9-Landing-Prediction/blob/main/6_SpaceX_Interactive_Folium.ipynb</a:t>
             </a:r>
           </a:p>
         </p:txBody>
@@ -5286,7 +5286,7 @@
               </a:defRPr>
             </a:pPr>
             <a:r>
-              <a:t>GitHub Repository Reference: https://github.com/your-username/SpaceX-Falcon9-Landing-Prediction/blob/main/6_SpaceX_Interactive_Folium.ipynb</a:t>
+              <a:t>GitHub Repository Reference: https://github.com/sondthe200221/SpaceX-Falcon9-Landing-Prediction/blob/main/6_SpaceX_Interactive_Folium.ipynb</a:t>
             </a:r>
           </a:p>
         </p:txBody>
@@ -5775,7 +5775,7 @@
               </a:defRPr>
             </a:pPr>
             <a:r>
-              <a:t>GitHub Repository Reference: https://github.com/your-username/SpaceX-Falcon9-Landing-Prediction/blob/main/7_spacex_dash_app.py</a:t>
+              <a:t>GitHub Repository Reference: https://github.com/sondthe200221/SpaceX-Falcon9-Landing-Prediction/blob/main/7_spacex_dash_app.py</a:t>
             </a:r>
           </a:p>
         </p:txBody>
@@ -6220,7 +6220,7 @@
               </a:defRPr>
             </a:pPr>
             <a:r>
-              <a:t>GitHub Repository Reference: https://github.com/your-username/SpaceX-Falcon9-Landing-Prediction/blob/main/8_SpaceX_Machine_Learning_Prediction.ipynb</a:t>
+              <a:t>GitHub Repository Reference: https://github.com/sondthe200221/SpaceX-Falcon9-Landing-Prediction/blob/main/8_SpaceX_Machine_Learning_Prediction.ipynb</a:t>
             </a:r>
           </a:p>
         </p:txBody>
@@ -6686,7 +6686,7 @@
               </a:defRPr>
             </a:pPr>
             <a:r>
-              <a:t>GitHub Repository Reference: https://github.com/your-username/SpaceX-Falcon9-Landing-Prediction</a:t>
+              <a:t>GitHub Repository Reference: https://github.com/sondthe200221/SpaceX-Falcon9-Landing-Prediction</a:t>
             </a:r>
           </a:p>
         </p:txBody>
@@ -7175,7 +7175,7 @@
               </a:defRPr>
             </a:pPr>
             <a:r>
-              <a:t>GitHub Repository Reference: https://github.com/your-username/SpaceX-Falcon9-Landing-Prediction</a:t>
+              <a:t>GitHub Repository Reference: https://github.com/sondthe200221/SpaceX-Falcon9-Landing-Prediction</a:t>
             </a:r>
           </a:p>
         </p:txBody>
@@ -7618,7 +7618,7 @@
               </a:defRPr>
             </a:pPr>
             <a:r>
-              <a:t>GitHub Repository Reference: https://github.com/your-username/SpaceX-Falcon9-Landing-Prediction</a:t>
+              <a:t>GitHub Repository Reference: https://github.com/sondthe200221/SpaceX-Falcon9-Landing-Prediction</a:t>
             </a:r>
           </a:p>
         </p:txBody>
@@ -8199,7 +8199,7 @@
               </a:defRPr>
             </a:pPr>
             <a:r>
-              <a:t>GitHub Repository Reference: https://github.com/your-username/SpaceX-Falcon9-Landing-Prediction/blob/main/1_SpaceX_Data_Collection_API.ipynb</a:t>
+              <a:t>GitHub Repository Reference: https://github.com/sondthe200221/SpaceX-Falcon9-Landing-Prediction/blob/main/1_SpaceX_Data_Collection_API.ipynb</a:t>
             </a:r>
           </a:p>
         </p:txBody>
@@ -8711,7 +8711,7 @@
               </a:defRPr>
             </a:pPr>
             <a:r>
-              <a:t>GitHub Repository Reference: https://github.com/your-username/SpaceX-Falcon9-Landing-Prediction/blob/main/2_SpaceX_Data_Collection_Web_Scraping.ipynb</a:t>
+              <a:t>GitHub Repository Reference: https://github.com/sondthe200221/SpaceX-Falcon9-Landing-Prediction/blob/main/2_SpaceX_Data_Collection_Web_Scraping.ipynb</a:t>
             </a:r>
           </a:p>
         </p:txBody>
@@ -9223,7 +9223,7 @@
               </a:defRPr>
             </a:pPr>
             <a:r>
-              <a:t>GitHub Repository Reference: https://github.com/your-username/SpaceX-Falcon9-Landing-Prediction/blob/main/3_SpaceX_Data_Wrangling.ipynb</a:t>
+              <a:t>GitHub Repository Reference: https://github.com/sondthe200221/SpaceX-Falcon9-Landing-Prediction/blob/main/3_SpaceX_Data_Wrangling.ipynb</a:t>
             </a:r>
           </a:p>
         </p:txBody>
@@ -9586,7 +9586,7 @@
               </a:defRPr>
             </a:pPr>
             <a:r>
-              <a:t>GitHub Repository Reference: https://github.com/your-username/SpaceX-Falcon9-Landing-Prediction/blob/main/4_SpaceX_EDA_Data_Visualization.ipynb</a:t>
+              <a:t>GitHub Repository Reference: https://github.com/sondthe200221/SpaceX-Falcon9-Landing-Prediction/blob/main/4_SpaceX_EDA_Data_Visualization.ipynb</a:t>
             </a:r>
           </a:p>
         </p:txBody>
@@ -10031,7 +10031,7 @@
               </a:defRPr>
             </a:pPr>
             <a:r>
-              <a:t>GitHub Repository Reference: https://github.com/your-username/SpaceX-Falcon9-Landing-Prediction/blob/main/4_SpaceX_EDA_Data_Visualization.ipynb</a:t>
+              <a:t>GitHub Repository Reference: https://github.com/sondthe200221/SpaceX-Falcon9-Landing-Prediction/blob/main/4_SpaceX_EDA_Data_Visualization.ipynb</a:t>
             </a:r>
           </a:p>
         </p:txBody>
@@ -10476,7 +10476,7 @@
               </a:defRPr>
             </a:pPr>
             <a:r>
-              <a:t>GitHub Repository Reference: https://github.com/your-username/SpaceX-Falcon9-Landing-Prediction/blob/main/4_SpaceX_EDA_Data_Visualization.ipynb</a:t>
+              <a:t>GitHub Repository Reference: https://github.com/sondthe200221/SpaceX-Falcon9-Landing-Prediction/blob/main/4_SpaceX_EDA_Data_Visualization.ipynb</a:t>
             </a:r>
           </a:p>
         </p:txBody>

</xml_diff>